<commit_message>
Put the full script into the deck's speaker notes
Co-Authored-By: Claude Sonnet 5.5 <noreply@anthropic.com>
Claude-Session: https://claude.ai/code/session_012EBs1xnLT9W2iz8UvfeSXm
</commit_message>
<xml_diff>
--- a/presentation/Deadline_Survival_Guide.pptx
+++ b/presentation/Deadline_Survival_Guide.pptx
@@ -113,20 +113,20 @@
   <p:extLst>
     <p:ext uri="{521415D9-36F7-43E2-AB2F-B90AF26B5E84}">
       <p14:sectionLst xmlns:p14="http://schemas.microsoft.com/office/powerpoint/2010/main">
-        <p14:section name="Opening" id="{6b90ddbe-eb0b-e435-6d77-26320f6460f4}">
+        <p14:section name="Opening" id="{9d130e6e-5857-d020-3a4c-af8f20eafdf6}">
           <p14:sldIdLst>
             <p14:sldId id="256"/>
             <p14:sldId id="257"/>
           </p14:sldIdLst>
         </p14:section>
-        <p14:section name="The system" id="{4482f554-1a01-8821-b181-807ada5a0b4b}">
+        <p14:section name="The system" id="{0dc9f525-a6b4-7ab2-7de3-39434bf51b0f}">
           <p14:sldIdLst>
             <p14:sldId id="258"/>
             <p14:sldId id="259"/>
             <p14:sldId id="260"/>
           </p14:sldIdLst>
         </p14:section>
-        <p14:section name="Close" id="{02a1c677-97dc-0e10-563a-824a9190a01a}">
+        <p14:section name="Close" id="{0cebac36-5a4f-d587-051a-45b9799a1227}">
           <p14:sldIdLst>
             <p14:sldId id="261"/>
             <p14:sldId id="262"/>
@@ -536,8 +536,11 @@
           <a:p>
             <a:r>
               <a:rPr lang="en-US" dirty="0"/>
-              <a:t>0:00-0:25 | OPENING + RAPPORT
-Smile, eye contact, wait for the room. Show of hands: 'I'll start tonight.' Laugh with them. Set one rule: keep questions until the end.</a:t>
+              <a:t>Title (0:00–0:25)
+[Walk to the front. Smile. Wait 2 seconds until the room is quiet.]
+Good morning, everyone! Before we start, one rule: please keep your questions until the end, and I promise I'll answer every one.
+Quick show of hands. [Raise your own hand.] Who here has ever said, "I'll start tonight," and then suddenly it's 2 a.m. and you've watched three episodes instead? [Pause. Smile at the hands.] Yes, me too!
+Today I'll show you three steps to survive deadlines, with no panic.</a:t>
             </a:r>
             <a:endParaRPr lang="en-US" dirty="0"/>
           </a:p>
@@ -625,8 +628,11 @@
           <a:p>
             <a:r>
               <a:rPr lang="en-US" dirty="0"/>
-              <a:t>0:25-0:55 | PROBLEM
-Most of us fail because we have no system, not because we are lazy. A juggling brain cannot focus. Don't try harder - work smarter: Dump, Sort, Block.</a:t>
+              <a:t>The deadline trap (0:25–0:55)
+[Click. Point at the three quotes.]
+Here's the thing. Most of us don't fail because we're lazy. We fail because we have no system.
+Our brain is juggling the essay, the group project, the exam, and the laundry, all at once. And a brain that is juggling can't focus.
+So don't try harder. Work smarter, with three steps: Dump. Sort. Block.</a:t>
             </a:r>
             <a:endParaRPr lang="en-US" dirty="0"/>
           </a:p>
@@ -714,8 +720,11 @@
           <a:p>
             <a:r>
               <a:rPr lang="en-US" dirty="0"/>
-              <a:t>0:55-1:30 | DUMP
-Write down EVERYTHING - big, small, boring, scary. Brain = great at ideas, terrible at storage. Once it's on the list your head is free. Try it tonight.</a:t>
+              <a:t>Step 1 · DUMP (0:55–1:30)
+[Click. Hold up one finger.]
+Step one: Dump. Take five minutes and write down everything you need to do. Big, small, boring, scary. Notes app, paper, anything. [Point at the sticky notes.] "Essay due Friday." "Email my professor." Even "do laundry." Every single thing goes on the list.
+Why? Because your brain is great at having ideas, but terrible at storing them. Once it's on the list, your head is free.
+Try it tonight. You'll feel lighter instantly.</a:t>
             </a:r>
             <a:endParaRPr lang="en-US" dirty="0"/>
           </a:p>
@@ -803,8 +812,13 @@
           <a:p>
             <a:r>
               <a:rPr lang="en-US" dirty="0"/>
-              <a:t>1:30-2:25 | SORT (Eisenhower Matrix)
-Two questions for every task: Urgent? Important? Do now / Schedule / Hand off / Delete. INTERACT: 'Is scrolling TikTok urgent? Important?' -&gt; pause -&gt; 'Delete.' Point at each box as you speak.</a:t>
+              <a:t>Step 2 · SORT (1:30–2:25)
+[Click. Hold up two fingers. Point at each box as you name it.]
+Step two: Sort. This is the Eisenhower Matrix, a simple four-box grid. For every task, ask two questions: Is it urgent? Is it important?
+Urgent and important? Do it now, like the essay due tomorrow.
+Important but not urgent? Schedule it, like studying for the midterm. This is where winners live.
+Urgent but not important, like a quick reply in the group chat? Hand it off, or do it fast.
+And neither? [Look at the audience.] Let me ask you: is scrolling TikTok urgent? Important? [Pause. Let them answer.] Exactly. Delete.</a:t>
             </a:r>
             <a:endParaRPr lang="en-US" dirty="0"/>
           </a:p>
@@ -892,8 +906,11 @@
           <a:p>
             <a:r>
               <a:rPr lang="en-US" dirty="0"/>
-              <a:t>2:25-3:05 | BLOCK (Pomodoro)
-Give each task a slot in your calendar. 25 min focus + 5 min break, repeat 4x, then a longer break. Breaks are part of the plan, not a reward. Point along the timeline.</a:t>
+              <a:t>Step 3 · BLOCK (2:25–3:05)
+[Click. Hold up three fingers. Slow down on the first line.]
+Step three: Block. A task without a time is just a wish.
+So give every task a slot in your calendar, and use the Pomodoro trick: 25 minutes of full focus, phone away, then a 5-minute break. After four rounds, take a longer one. [Sweep your hand along the timeline.] For example, take "study for the midterm" from your Schedule box and give it a start time: Tuesday, 7 p.m.
+Short sprints beat long, painful marathons. And breaks are part of the plan, not a reward for finishing.</a:t>
             </a:r>
             <a:endParaRPr lang="en-US" dirty="0"/>
           </a:p>
@@ -981,8 +998,13 @@
           <a:p>
             <a:r>
               <a:rPr lang="en-US" dirty="0"/>
-              <a:t>3:05-3:40 | CLOSE + CALL TO ACTION
-Repeat: Dump it, Sort it, Block it. Challenge for tonight. Closing line: 'Your future self - the one with no 2 a.m. panic - will thank you.' Thank the audience and invite questions. Then switch to the Q&amp;A slide.</a:t>
+              <a:t>Recap + challenge (3:05–3:40)
+[Click. Slow down. Look at the whole room.]
+So remember: Dump it. Sort it. Block it.
+Here's your challenge. Tonight, take just five minutes: dump your tasks, pick your top three, and block time for the first one. That's it.
+A small system makes a big change. And your future self, the one with no 2 a.m. panic, will thank you.
+Thank you! [Smile. Pause.] I'd be happy to take your questions.
+[Click to Slide 7.]</a:t>
             </a:r>
             <a:endParaRPr lang="en-US" dirty="0"/>
           </a:p>
@@ -1070,7 +1092,25 @@
           <a:p>
             <a:r>
               <a:rPr lang="en-US" dirty="0"/>
-              <a:t>Q&amp;A | For each question: THANK the questioner -&gt; COMMENT ('Good point') -&gt; ANSWER -&gt; CHECK ('Does that answer your question?'). See SCRIPT.md for the question bank.</a:t>
+              <a:t>Q&amp;A CHEAT SHEET
+For every good question, use this 4-step pattern:
+Thank → Comment → Answer → Check
+### 1. Good question
+Q: "What if everything feels urgent?"
+Thank/Comment: "Thank you, that's a very good question. I'm glad you asked."
+Answer: "Then ask one more question: what happens if I do this tomorrow? If the answer is 'nothing bad,' it's not truly urgent. Start with the item with the real consequence or the closest deadline, and the rest can wait."
+Check: "Does that help?"
+### 2. Difficult question
+Q: "Doesn't Pomodoro fail if I'm already in the flow?"
+Answer: "Good point. If you're deeply focused, keep going. The timer is a tool, not a rule. Use it to start, and ignore it when you're on a roll. Take your break when the flow ends."
+If you don't know: "That's a great question and I don't have the full answer. Let me find out and email you after class."
+### 3. Unnecessary question (already covered)
+Q: "Sorry, how long is one Pomodoro?"
+Answer: Stay kind. Never say "I already said that." → "Thanks for checking! 25 minutes of focus, then a 5-minute break. Does that make sense?"
+### 4. Irrelevant question
+Q: "Which phone do you use?"
+Answer: "Thanks for asking, but that's a bit off-topic. Let's chat about it after class so we can stay on task management."
+---</a:t>
             </a:r>
             <a:endParaRPr lang="en-US" dirty="0"/>
           </a:p>

</xml_diff>